<commit_message>
발표 PPT 글꼴을 제목 Pretendard, 본문 Pretendard SemiBold로 변경
발표자가 직접 고친 파일의 글꼴에 맞춤. 코드 창은 JetBrains Mono 유지.

Co-Authored-By: Claude Opus 5.5 <noreply@anthropic.com>
Claude-Session: https://claude.ai/code/session_01CZVM9D7xaiJyCCw2JrofgF
</commit_message>
<xml_diff>
--- a/발표/RESTful-API-설계.pptx
+++ b/발표/RESTful-API-설계.pptx
@@ -140,7 +140,7 @@
   <p:extLst>
     <p:ext uri="{521415D9-36F7-43E2-AB2F-B90AF26B5E84}">
       <p14:sectionLst xmlns:p14="http://schemas.microsoft.com/office/powerpoint/2010/main">
-        <p14:section name="시작" id="{234d0fd2-0b7c-49ba-ea6b-5c32903fbae9}">
+        <p14:section name="시작" id="{a69b3c41-a3e8-9a06-0a3b-0e7f56eee222}">
           <p14:sldIdLst>
             <p14:sldId id="256"/>
             <p14:sldId id="257"/>
@@ -149,32 +149,32 @@
             <p14:sldId id="260"/>
           </p14:sldIdLst>
         </p14:section>
-        <p14:section name="01 자원 중심 URL" id="{de70756d-a4d4-57b9-22d2-4448ef69a3a8}">
+        <p14:section name="01 자원 중심 URL" id="{df121def-56c8-e578-ac3d-5131ce9b8df4}">
           <p14:sldIdLst>
             <p14:sldId id="261"/>
             <p14:sldId id="262"/>
             <p14:sldId id="263"/>
           </p14:sldIdLst>
         </p14:section>
-        <p14:section name="02 HTTP 메서드와 상태 코드" id="{a26333ea-e879-14a2-4547-833e97d21c62}">
+        <p14:section name="02 HTTP 메서드와 상태 코드" id="{57725d79-5026-43d5-bd4b-2f9007c5b9a0}">
           <p14:sldIdLst>
             <p14:sldId id="264"/>
             <p14:sldId id="265"/>
             <p14:sldId id="266"/>
           </p14:sldIdLst>
         </p14:section>
-        <p14:section name="03 공통 응답과 에러 형식" id="{e90af2fb-240a-536e-a530-4734aec67399}">
+        <p14:section name="03 공통 응답과 에러 형식" id="{d4a309c2-9997-45f5-7b4b-053bc7c70e3a}">
           <p14:sldIdLst>
             <p14:sldId id="267"/>
           </p14:sldIdLst>
         </p14:section>
-        <p14:section name="04 전역 예외 처리와 입력 검증" id="{0fe933b6-4795-7c18-e362-c263e4df7695}">
+        <p14:section name="04 전역 예외 처리와 입력 검증" id="{821d7c47-8639-5af4-565e-df4936579e34}">
           <p14:sldIdLst>
             <p14:sldId id="268"/>
             <p14:sldId id="269"/>
           </p14:sldIdLst>
         </p14:section>
-        <p14:section name="05 페이징 · 검색 · 정렬" id="{44fdf30f-3c0c-7a88-ae3b-a95aef5fab94}">
+        <p14:section name="05 페이징 · 검색 · 정렬" id="{fe4cd253-1ae4-4292-e9df-013835cc86b1}">
           <p14:sldIdLst>
             <p14:sldId id="270"/>
             <p14:sldId id="271"/>
@@ -183,7 +183,7 @@
             <p14:sldId id="274"/>
           </p14:sldIdLst>
         </p14:section>
-        <p14:section name="06 API 문서" id="{8a86525a-a2c6-aac5-1379-48ef24590a06}">
+        <p14:section name="06 API 문서" id="{34373cc7-84da-0781-cf56-6d3fa8fec063}">
           <p14:sldIdLst>
             <p14:sldId id="275"/>
             <p14:sldId id="276"/>
@@ -191,12 +191,12 @@
             <p14:sldId id="278"/>
           </p14:sldIdLst>
         </p14:section>
-        <p14:section name="정리" id="{731ce9b9-4a76-be1e-9932-bf831d383a5a}">
+        <p14:section name="정리" id="{e13b9443-642b-1ad9-ca30-ab34a983b838}">
           <p14:sldIdLst>
             <p14:sldId id="279"/>
           </p14:sldIdLst>
         </p14:section>
-        <p14:section name="예비 (질문이 나오면)" id="{18462acd-30a4-58a3-37fb-614cbecc2241}">
+        <p14:section name="예비 (질문이 나오면)" id="{b0434beb-412f-5efc-ba0e-47bd0c9b4bc2}">
           <p14:sldIdLst>
             <p14:sldId id="280"/>
             <p14:sldId id="281"/>
@@ -14307,11 +14307,11 @@
         <p:spPr>
           <a:xfrm>
             <a:off x="649224" y="2153412"/>
-            <a:ext cx="5330952" cy="2080895"/>
+            <a:ext cx="5330952" cy="1922145"/>
           </a:xfrm>
           <a:prstGeom prst="roundRect">
             <a:avLst>
-              <a:gd name="adj" fmla="val 5273"/>
+              <a:gd name="adj" fmla="val 5709"/>
             </a:avLst>
           </a:prstGeom>
           <a:solidFill>
@@ -14431,7 +14431,7 @@
         <p:spPr>
           <a:xfrm>
             <a:off x="905256" y="2592324"/>
-            <a:ext cx="4873752" cy="1532255"/>
+            <a:ext cx="4873752" cy="1373505"/>
           </a:xfrm>
           <a:prstGeom prst="rect">
             <a:avLst/>
@@ -14450,7 +14450,7 @@
               <a:buNone/>
             </a:pPr>
             <a:r>
-              <a:rPr lang="en-US" sz="1700" dirty="0">
+              <a:rPr lang="en-US" sz="1500" dirty="0">
                 <a:solidFill>
                   <a:srgbClr val="E5806F"/>
                 </a:solidFill>
@@ -14460,7 +14460,7 @@
               </a:rPr>
               <a:t>POST /deletePost.do?no=42</a:t>
             </a:r>
-            <a:endParaRPr lang="en-US" sz="1700" dirty="0"/>
+            <a:endParaRPr lang="en-US" sz="1500" dirty="0"/>
           </a:p>
           <a:p>
             <a:pPr algn="l" indent="0" marL="0">
@@ -14470,7 +14470,7 @@
               <a:buNone/>
             </a:pPr>
             <a:r>
-              <a:rPr lang="en-US" sz="1700" dirty="0">
+              <a:rPr lang="en-US" sz="1500" dirty="0">
                 <a:solidFill>
                   <a:srgbClr val="E5806F"/>
                 </a:solidFill>
@@ -14480,7 +14480,7 @@
               </a:rPr>
               <a:t>GET  /post/remove?id=42</a:t>
             </a:r>
-            <a:endParaRPr lang="en-US" sz="1700" dirty="0"/>
+            <a:endParaRPr lang="en-US" sz="1500" dirty="0"/>
           </a:p>
           <a:p>
             <a:pPr algn="l" indent="0" marL="0">
@@ -14490,7 +14490,7 @@
               <a:buNone/>
             </a:pPr>
             <a:r>
-              <a:rPr lang="en-US" sz="1700" dirty="0">
+              <a:rPr lang="en-US" sz="1500" dirty="0">
                 <a:solidFill>
                   <a:srgbClr val="E5806F"/>
                 </a:solidFill>
@@ -14500,7 +14500,7 @@
               </a:rPr>
               <a:t>POST /api  {"action":"delete","id":42}</a:t>
             </a:r>
-            <a:endParaRPr lang="en-US" sz="1700" dirty="0"/>
+            <a:endParaRPr lang="en-US" sz="1500" dirty="0"/>
           </a:p>
           <a:p>
             <a:pPr algn="l" indent="0" marL="0">
@@ -14510,7 +14510,7 @@
               <a:buNone/>
             </a:pPr>
             <a:r>
-              <a:rPr lang="en-US" sz="1700" dirty="0">
+              <a:rPr lang="en-US" sz="1500" dirty="0">
                 <a:solidFill>
                   <a:srgbClr val="FAF9F5"/>
                 </a:solidFill>
@@ -14520,7 +14520,7 @@
               </a:rPr>
               <a:t> </a:t>
             </a:r>
-            <a:endParaRPr lang="en-US" sz="1700" dirty="0"/>
+            <a:endParaRPr lang="en-US" sz="1500" dirty="0"/>
           </a:p>
           <a:p>
             <a:pPr algn="l" indent="0" marL="0">
@@ -14530,7 +14530,7 @@
               <a:buNone/>
             </a:pPr>
             <a:r>
-              <a:rPr lang="en-US" sz="1700" dirty="0">
+              <a:rPr lang="en-US" sz="1500" dirty="0">
                 <a:solidFill>
                   <a:srgbClr val="A09D96"/>
                 </a:solidFill>
@@ -14540,7 +14540,7 @@
               </a:rPr>
               <a:t>→ 쓰는 쪽은 API마다 문서를 찾거나 물어봐야 한다</a:t>
             </a:r>
-            <a:endParaRPr lang="en-US" sz="1700" dirty="0"/>
+            <a:endParaRPr lang="en-US" sz="1500" dirty="0"/>
           </a:p>
         </p:txBody>
       </p:sp>
@@ -14553,11 +14553,11 @@
         <p:spPr>
           <a:xfrm>
             <a:off x="6208776" y="2153412"/>
-            <a:ext cx="5330952" cy="2080895"/>
+            <a:ext cx="5330952" cy="1922145"/>
           </a:xfrm>
           <a:prstGeom prst="roundRect">
             <a:avLst>
-              <a:gd name="adj" fmla="val 5273"/>
+              <a:gd name="adj" fmla="val 5709"/>
             </a:avLst>
           </a:prstGeom>
           <a:solidFill>
@@ -14677,7 +14677,7 @@
         <p:spPr>
           <a:xfrm>
             <a:off x="6464808" y="2592324"/>
-            <a:ext cx="4873752" cy="1532255"/>
+            <a:ext cx="4873752" cy="1373505"/>
           </a:xfrm>
           <a:prstGeom prst="rect">
             <a:avLst/>
@@ -14696,7 +14696,7 @@
               <a:buNone/>
             </a:pPr>
             <a:r>
-              <a:rPr lang="en-US" sz="1700" dirty="0">
+              <a:rPr lang="en-US" sz="1500" dirty="0">
                 <a:solidFill>
                   <a:srgbClr val="FAF9F5"/>
                 </a:solidFill>
@@ -14706,7 +14706,7 @@
               </a:rPr>
               <a:t>DELETE /api/v1/posts/42</a:t>
             </a:r>
-            <a:endParaRPr lang="en-US" sz="1700" dirty="0"/>
+            <a:endParaRPr lang="en-US" sz="1500" dirty="0"/>
           </a:p>
           <a:p>
             <a:pPr algn="l" indent="0" marL="0">
@@ -14716,7 +14716,7 @@
               <a:buNone/>
             </a:pPr>
             <a:r>
-              <a:rPr lang="en-US" sz="1700" dirty="0">
+              <a:rPr lang="en-US" sz="1500" dirty="0">
                 <a:solidFill>
                   <a:srgbClr val="5DB872"/>
                 </a:solidFill>
@@ -14726,7 +14726,7 @@
               </a:rPr>
               <a:t>→ 204 No Content</a:t>
             </a:r>
-            <a:endParaRPr lang="en-US" sz="1700" dirty="0"/>
+            <a:endParaRPr lang="en-US" sz="1500" dirty="0"/>
           </a:p>
           <a:p>
             <a:pPr algn="l" indent="0" marL="0">
@@ -14736,7 +14736,7 @@
               <a:buNone/>
             </a:pPr>
             <a:r>
-              <a:rPr lang="en-US" sz="1700" dirty="0">
+              <a:rPr lang="en-US" sz="1500" dirty="0">
                 <a:solidFill>
                   <a:srgbClr val="FAF9F5"/>
                 </a:solidFill>
@@ -14746,7 +14746,7 @@
               </a:rPr>
               <a:t> </a:t>
             </a:r>
-            <a:endParaRPr lang="en-US" sz="1700" dirty="0"/>
+            <a:endParaRPr lang="en-US" sz="1500" dirty="0"/>
           </a:p>
           <a:p>
             <a:pPr algn="l" indent="0" marL="0">
@@ -14756,7 +14756,7 @@
               <a:buNone/>
             </a:pPr>
             <a:r>
-              <a:rPr lang="en-US" sz="1700" dirty="0">
+              <a:rPr lang="en-US" sz="1500" dirty="0">
                 <a:solidFill>
                   <a:srgbClr val="FAF9F5"/>
                 </a:solidFill>
@@ -14766,7 +14766,7 @@
               </a:rPr>
               <a:t> </a:t>
             </a:r>
-            <a:endParaRPr lang="en-US" sz="1700" dirty="0"/>
+            <a:endParaRPr lang="en-US" sz="1500" dirty="0"/>
           </a:p>
           <a:p>
             <a:pPr algn="l" indent="0" marL="0">
@@ -14776,7 +14776,7 @@
               <a:buNone/>
             </a:pPr>
             <a:r>
-              <a:rPr lang="en-US" sz="1700" dirty="0">
+              <a:rPr lang="en-US" sz="1500" dirty="0">
                 <a:solidFill>
                   <a:srgbClr val="A09D96"/>
                 </a:solidFill>
@@ -14786,7 +14786,7 @@
               </a:rPr>
               <a:t>→ 주소만 보고도 무슨 일인지 알 수 있다</a:t>
             </a:r>
-            <a:endParaRPr lang="en-US" sz="1700" dirty="0"/>
+            <a:endParaRPr lang="en-US" sz="1500" dirty="0"/>
           </a:p>
         </p:txBody>
       </p:sp>
@@ -14798,7 +14798,7 @@
         </p:nvSpPr>
         <p:spPr>
           <a:xfrm>
-            <a:off x="649224" y="4462907"/>
+            <a:off x="649224" y="4304157"/>
             <a:ext cx="10890504" cy="408940"/>
           </a:xfrm>
           <a:prstGeom prst="rect">
@@ -15038,7 +15038,7 @@
       </p:sp>
       <p:pic>
         <p:nvPicPr>
-          <p:cNvPr id="6" name="screenshot" descr="/tmp/ccp-857-cv3n5hopadl.png">    </p:cNvPr>
+          <p:cNvPr id="6" name="screenshot" descr="/tmp/ccp-384-1ak2j7qu2q4.png">    </p:cNvPr>
           <p:cNvPicPr>
             <a:picLocks noChangeAspect="1"/>
           </p:cNvPicPr>
@@ -15288,7 +15288,7 @@
       </p:sp>
       <p:pic>
         <p:nvPicPr>
-          <p:cNvPr id="6" name="screenshot" descr="/tmp/ccp-857-aevilgy2rmt.png">    </p:cNvPr>
+          <p:cNvPr id="6" name="screenshot" descr="/tmp/ccp-384-j7rgb43fup9.png">    </p:cNvPr>
           <p:cNvPicPr>
             <a:picLocks noChangeAspect="1"/>
           </p:cNvPicPr>
@@ -15334,7 +15334,7 @@
       </p:sp>
       <p:pic>
         <p:nvPicPr>
-          <p:cNvPr id="8" name="screenshot" descr="/tmp/ccp-857-nvf0ktzpyki.png">    </p:cNvPr>
+          <p:cNvPr id="8" name="screenshot" descr="/tmp/ccp-384-igxtrha3u6d.png">    </p:cNvPr>
           <p:cNvPicPr>
             <a:picLocks noChangeAspect="1"/>
           </p:cNvPicPr>
@@ -15584,7 +15584,7 @@
       </p:sp>
       <p:pic>
         <p:nvPicPr>
-          <p:cNvPr id="6" name="screenshot" descr="/tmp/ccp-857-srdgh01s4ue.png">    </p:cNvPr>
+          <p:cNvPr id="6" name="screenshot" descr="/tmp/ccp-384-nb7g88h57n.png">    </p:cNvPr>
           <p:cNvPicPr>
             <a:picLocks noChangeAspect="1"/>
           </p:cNvPicPr>
@@ -15834,7 +15834,7 @@
       </p:sp>
       <p:pic>
         <p:nvPicPr>
-          <p:cNvPr id="6" name="screenshot" descr="/tmp/ccp-857-4pwn7lvxwc5.png">    </p:cNvPr>
+          <p:cNvPr id="6" name="screenshot" descr="/tmp/ccp-384-acijlp2sh1v.png">    </p:cNvPr>
           <p:cNvPicPr>
             <a:picLocks noChangeAspect="1"/>
           </p:cNvPicPr>
@@ -21521,7 +21521,7 @@
       </p:sp>
       <p:pic>
         <p:nvPicPr>
-          <p:cNvPr id="6" name="screenshot" descr="/tmp/ccp-857-3ee4an7bh1.png">    </p:cNvPr>
+          <p:cNvPr id="6" name="screenshot" descr="/tmp/ccp-384-97fadz176g.png">    </p:cNvPr>
           <p:cNvPicPr>
             <a:picLocks noChangeAspect="1"/>
           </p:cNvPicPr>
@@ -21771,7 +21771,7 @@
       </p:sp>
       <p:pic>
         <p:nvPicPr>
-          <p:cNvPr id="6" name="screenshot" descr="/tmp/ccp-857-ww80rw78j9i.png">    </p:cNvPr>
+          <p:cNvPr id="6" name="screenshot" descr="/tmp/ccp-384-fbuexd8xyhd.png">    </p:cNvPr>
           <p:cNvPicPr>
             <a:picLocks noChangeAspect="1"/>
           </p:cNvPicPr>
@@ -21817,7 +21817,7 @@
       </p:sp>
       <p:pic>
         <p:nvPicPr>
-          <p:cNvPr id="8" name="screenshot" descr="/tmp/ccp-857-j54x0xe0zme.png">    </p:cNvPr>
+          <p:cNvPr id="8" name="screenshot" descr="/tmp/ccp-384-1k88meavo1y.png">    </p:cNvPr>
           <p:cNvPicPr>
             <a:picLocks noChangeAspect="1"/>
           </p:cNvPicPr>
@@ -21863,7 +21863,7 @@
       </p:sp>
       <p:pic>
         <p:nvPicPr>
-          <p:cNvPr id="10" name="screenshot" descr="/tmp/ccp-857-23an5ciy1jy.png">    </p:cNvPr>
+          <p:cNvPr id="10" name="screenshot" descr="/tmp/ccp-384-ltxm0p15p5a.png">    </p:cNvPr>
           <p:cNvPicPr>
             <a:picLocks noChangeAspect="1"/>
           </p:cNvPicPr>
@@ -30505,11 +30505,11 @@
     </a:clrScheme>
     <a:fontScheme name="Cream Coral">
       <a:majorFont>
-        <a:latin typeface="Noto Serif KR"/>
-        <a:ea typeface="Noto Serif KR"/>
+        <a:latin typeface="Pretendard"/>
+        <a:ea typeface="Pretendard"/>
         <a:cs typeface=""/>
         <a:font script="Jpan" typeface="游ゴシック Light"/>
-        <a:font script="Hang" typeface="Noto Serif KR"/>
+        <a:font script="Hang" typeface="Pretendard"/>
         <a:font script="Hans" typeface="等线 Light"/>
         <a:font script="Hant" typeface="新細明體"/>
         <a:font script="Arab" typeface="Times New Roman"/>
@@ -30557,11 +30557,11 @@
         <a:font script="Tfng" typeface="Ebrima"/>
       </a:majorFont>
       <a:minorFont>
-        <a:latin typeface="Pretendard"/>
-        <a:ea typeface="Pretendard"/>
+        <a:latin typeface="Pretendard SemiBold"/>
+        <a:ea typeface="Pretendard SemiBold"/>
         <a:cs typeface=""/>
         <a:font script="Jpan" typeface="游ゴシック"/>
-        <a:font script="Hang" typeface="Pretendard"/>
+        <a:font script="Hang" typeface="Pretendard SemiBold"/>
         <a:font script="Hans" typeface="等线"/>
         <a:font script="Hant" typeface="新細明體"/>
         <a:font script="Arab" typeface="Arial"/>

</xml_diff>